<commit_message>
make the workflow slide show what runs where
</commit_message>
<xml_diff>
--- a/docs/presentations/EnzymeX_BLAST_HMMER_update.pptx
+++ b/docs/presentations/EnzymeX_BLAST_HMMER_update.pptx
@@ -580,7 +580,7 @@
           <a:lstStyle/>
           <a:p>
             <a:r>
-              <a:t>Standalone test server. The search core is a library, so EnzymeX can call run_search from its existing scheduled job without taking any of the web code.</a:t>
+              <a:t>Steps 1 and 2 are the reference build. Steps 3 to 5 are one user request. The search code between them is a plain function with no web framework in it, so EnzymeX calls it from its existing scheduled job rather than taking any of my web layer.</a:t>
             </a:r>
           </a:p>
         </p:txBody>
@@ -4618,7 +4618,7 @@
                 </a:solidFill>
                 <a:latin typeface="Malgun Gothic"/>
               </a:rPr>
-              <a:t>Overview</a:t>
+              <a:t>Workflow: what happens, and where</a:t>
             </a:r>
           </a:p>
         </p:txBody>
@@ -4666,8 +4666,8 @@
         </p:nvSpPr>
         <p:spPr>
           <a:xfrm>
-            <a:off x="658368" y="1600200"/>
-            <a:ext cx="1874519" cy="960120"/>
+            <a:off x="658368" y="1481328"/>
+            <a:ext cx="2048256" cy="2487168"/>
           </a:xfrm>
           <a:prstGeom prst="roundRect">
             <a:avLst/>
@@ -4705,14 +4705,59 @@
       </p:sp>
       <p:sp>
         <p:nvSpPr>
-          <p:cNvPr id="6" name="TextBox 5"/>
+          <p:cNvPr id="6" name="Rectangle 5"/>
+          <p:cNvSpPr/>
+          <p:nvPr/>
+        </p:nvSpPr>
+        <p:spPr>
+          <a:xfrm>
+            <a:off x="658368" y="1481328"/>
+            <a:ext cx="2048256" cy="420624"/>
+          </a:xfrm>
+          <a:prstGeom prst="rect">
+            <a:avLst/>
+          </a:prstGeom>
+          <a:solidFill>
+            <a:srgbClr val="B71A1A"/>
+          </a:solidFill>
+          <a:ln>
+            <a:solidFill>
+              <a:srgbClr val="B71A1A"/>
+            </a:solidFill>
+          </a:ln>
+        </p:spPr>
+        <p:style>
+          <a:lnRef idx="1">
+            <a:schemeClr val="accent1"/>
+          </a:lnRef>
+          <a:fillRef idx="3">
+            <a:schemeClr val="accent1"/>
+          </a:fillRef>
+          <a:effectRef idx="2">
+            <a:schemeClr val="accent1"/>
+          </a:effectRef>
+          <a:fontRef idx="minor">
+            <a:schemeClr val="lt1"/>
+          </a:fontRef>
+        </p:style>
+        <p:txBody>
+          <a:bodyPr rtlCol="0" anchor="ctr"/>
+          <a:lstStyle/>
+          <a:p>
+            <a:pPr algn="ctr"/>
+          </a:p>
+        </p:txBody>
+      </p:sp>
+      <p:sp>
+        <p:nvSpPr>
+          <p:cNvPr id="7" name="TextBox 6"/>
           <p:cNvSpPr txBox="1"/>
           <p:nvPr/>
         </p:nvSpPr>
         <p:spPr>
           <a:xfrm>
-            <a:off x="841247" y="1810512"/>
-            <a:ext cx="1554480" cy="274320"/>
+            <a:off x="841247" y="1572768"/>
+            <a:ext cx="1737360" cy="256032"/>
           </a:xfrm>
           <a:prstGeom prst="rect">
             <a:avLst/>
@@ -4727,27 +4772,27 @@
           <a:p>
             <a:pPr algn="l"/>
             <a:r>
-              <a:rPr sz="1350" b="1">
-                <a:solidFill>
-                  <a:srgbClr val="18212B"/>
-                </a:solidFill>
-                <a:latin typeface="Malgun Gothic"/>
-              </a:rPr>
-              <a:t>Copied DB</a:t>
-            </a:r>
-          </a:p>
-        </p:txBody>
-      </p:sp>
-      <p:sp>
-        <p:nvSpPr>
-          <p:cNvPr id="7" name="TextBox 6"/>
+              <a:rPr sz="1400" b="1">
+                <a:solidFill>
+                  <a:srgbClr val="FFFFFF"/>
+                </a:solidFill>
+                <a:latin typeface="Malgun Gothic"/>
+              </a:rPr>
+              <a:t>1   Export</a:t>
+            </a:r>
+          </a:p>
+        </p:txBody>
+      </p:sp>
+      <p:sp>
+        <p:nvSpPr>
+          <p:cNvPr id="8" name="TextBox 7"/>
           <p:cNvSpPr txBox="1"/>
           <p:nvPr/>
         </p:nvSpPr>
         <p:spPr>
           <a:xfrm>
-            <a:off x="841247" y="2139696"/>
-            <a:ext cx="1554480" cy="237744"/>
+            <a:off x="841247" y="2048256"/>
+            <a:ext cx="1700784" cy="1234440"/>
           </a:xfrm>
           <a:prstGeom prst="rect">
             <a:avLst/>
@@ -4760,29 +4805,103 @@
           </a:bodyPr>
           <a:lstStyle/>
           <a:p>
+            <a:pPr algn="l">
+              <a:lnSpc>
+                <a:spcPct val="112000"/>
+              </a:lnSpc>
+            </a:pPr>
+            <a:r>
+              <a:rPr sz="1150" b="0">
+                <a:solidFill>
+                  <a:srgbClr val="18212B"/>
+                </a:solidFill>
+                <a:latin typeface="Malgun Gothic"/>
+              </a:rPr>
+              <a:t>Read the copied table once. Keep Swiss-Prot and PDB, drop bad rows, remove duplicates.</a:t>
+            </a:r>
+          </a:p>
+        </p:txBody>
+      </p:sp>
+      <p:cxnSp>
+        <p:nvCxnSpPr>
+          <p:cNvPr id="9" name="Connector 8"/>
+          <p:cNvCxnSpPr/>
+          <p:nvPr/>
+        </p:nvCxnSpPr>
+        <p:spPr>
+          <a:xfrm>
+            <a:off x="841247" y="3310128"/>
+            <a:ext cx="1682497" cy="0"/>
+          </a:xfrm>
+          <a:prstGeom prst="line">
+            <a:avLst/>
+          </a:prstGeom>
+          <a:ln w="12700">
+            <a:solidFill>
+              <a:srgbClr val="D9DEE7"/>
+            </a:solidFill>
+          </a:ln>
+        </p:spPr>
+        <p:style>
+          <a:lnRef idx="2">
+            <a:schemeClr val="accent1"/>
+          </a:lnRef>
+          <a:fillRef idx="0">
+            <a:schemeClr val="accent1"/>
+          </a:fillRef>
+          <a:effectRef idx="1">
+            <a:schemeClr val="accent1"/>
+          </a:effectRef>
+          <a:fontRef idx="minor">
+            <a:schemeClr val="tx1"/>
+          </a:fontRef>
+        </p:style>
+      </p:cxnSp>
+      <p:sp>
+        <p:nvSpPr>
+          <p:cNvPr id="10" name="TextBox 9"/>
+          <p:cNvSpPr txBox="1"/>
+          <p:nvPr/>
+        </p:nvSpPr>
+        <p:spPr>
+          <a:xfrm>
+            <a:off x="841247" y="3401568"/>
+            <a:ext cx="1737360" cy="457200"/>
+          </a:xfrm>
+          <a:prstGeom prst="rect">
+            <a:avLst/>
+          </a:prstGeom>
+          <a:noFill/>
+        </p:spPr>
+        <p:txBody>
+          <a:bodyPr wrap="square" lIns="0" rIns="0" tIns="0" bIns="0" anchor="t">
+            <a:noAutofit/>
+          </a:bodyPr>
+          <a:lstStyle/>
+          <a:p>
             <a:pPr algn="l"/>
             <a:r>
-              <a:rPr sz="1050" b="0">
+              <a:rPr sz="950" b="0">
                 <a:solidFill>
                   <a:srgbClr val="667085"/>
                 </a:solidFill>
-                <a:latin typeface="Malgun Gothic"/>
-              </a:rPr>
-              <a:t>read-only</a:t>
-            </a:r>
-          </a:p>
-        </p:txBody>
-      </p:sp>
-      <p:sp>
-        <p:nvSpPr>
-          <p:cNvPr id="8" name="Right Arrow 7"/>
+                <a:latin typeface="Consolas"/>
+              </a:rPr>
+              <a:t>PyMySQL  -&gt;  FASTA</a:t>
+            </a:r>
+          </a:p>
+        </p:txBody>
+      </p:sp>
+      <p:sp>
+        <p:nvSpPr>
+          <p:cNvPr id="11" name="Right Arrow 10"/>
           <p:cNvSpPr/>
           <p:nvPr/>
         </p:nvSpPr>
         <p:spPr>
           <a:xfrm>
-            <a:off x="2596896" y="1938528"/>
-            <a:ext cx="219456" cy="292608"/>
+            <a:off x="2729484" y="2596896"/>
+            <a:ext cx="137160" cy="219456"/>
           </a:xfrm>
           <a:prstGeom prst="rightArrow">
             <a:avLst/>
@@ -4820,14 +4939,14 @@
       </p:sp>
       <p:sp>
         <p:nvSpPr>
-          <p:cNvPr id="9" name="Rounded Rectangle 8"/>
+          <p:cNvPr id="12" name="Rounded Rectangle 11"/>
           <p:cNvSpPr/>
           <p:nvPr/>
         </p:nvSpPr>
         <p:spPr>
           <a:xfrm>
-            <a:off x="2871215" y="1600200"/>
-            <a:ext cx="1874519" cy="960120"/>
+            <a:off x="2871215" y="1481328"/>
+            <a:ext cx="2048256" cy="2487168"/>
           </a:xfrm>
           <a:prstGeom prst="roundRect">
             <a:avLst/>
@@ -4865,14 +4984,59 @@
       </p:sp>
       <p:sp>
         <p:nvSpPr>
-          <p:cNvPr id="10" name="TextBox 9"/>
+          <p:cNvPr id="13" name="Rectangle 12"/>
+          <p:cNvSpPr/>
+          <p:nvPr/>
+        </p:nvSpPr>
+        <p:spPr>
+          <a:xfrm>
+            <a:off x="2871215" y="1481328"/>
+            <a:ext cx="2048256" cy="420624"/>
+          </a:xfrm>
+          <a:prstGeom prst="rect">
+            <a:avLst/>
+          </a:prstGeom>
+          <a:solidFill>
+            <a:srgbClr val="B71A1A"/>
+          </a:solidFill>
+          <a:ln>
+            <a:solidFill>
+              <a:srgbClr val="B71A1A"/>
+            </a:solidFill>
+          </a:ln>
+        </p:spPr>
+        <p:style>
+          <a:lnRef idx="1">
+            <a:schemeClr val="accent1"/>
+          </a:lnRef>
+          <a:fillRef idx="3">
+            <a:schemeClr val="accent1"/>
+          </a:fillRef>
+          <a:effectRef idx="2">
+            <a:schemeClr val="accent1"/>
+          </a:effectRef>
+          <a:fontRef idx="minor">
+            <a:schemeClr val="lt1"/>
+          </a:fontRef>
+        </p:style>
+        <p:txBody>
+          <a:bodyPr rtlCol="0" anchor="ctr"/>
+          <a:lstStyle/>
+          <a:p>
+            <a:pPr algn="ctr"/>
+          </a:p>
+        </p:txBody>
+      </p:sp>
+      <p:sp>
+        <p:nvSpPr>
+          <p:cNvPr id="14" name="TextBox 13"/>
           <p:cNvSpPr txBox="1"/>
           <p:nvPr/>
         </p:nvSpPr>
         <p:spPr>
           <a:xfrm>
-            <a:off x="3054096" y="1810512"/>
-            <a:ext cx="1554480" cy="274320"/>
+            <a:off x="3054096" y="1572768"/>
+            <a:ext cx="1737360" cy="256032"/>
           </a:xfrm>
           <a:prstGeom prst="rect">
             <a:avLst/>
@@ -4887,27 +5051,27 @@
           <a:p>
             <a:pPr algn="l"/>
             <a:r>
-              <a:rPr sz="1350" b="1">
-                <a:solidFill>
-                  <a:srgbClr val="18212B"/>
-                </a:solidFill>
-                <a:latin typeface="Malgun Gothic"/>
-              </a:rPr>
-              <a:t>Offline build</a:t>
-            </a:r>
-          </a:p>
-        </p:txBody>
-      </p:sp>
-      <p:sp>
-        <p:nvSpPr>
-          <p:cNvPr id="11" name="TextBox 10"/>
+              <a:rPr sz="1400" b="1">
+                <a:solidFill>
+                  <a:srgbClr val="FFFFFF"/>
+                </a:solidFill>
+                <a:latin typeface="Malgun Gothic"/>
+              </a:rPr>
+              <a:t>2   Index</a:t>
+            </a:r>
+          </a:p>
+        </p:txBody>
+      </p:sp>
+      <p:sp>
+        <p:nvSpPr>
+          <p:cNvPr id="15" name="TextBox 14"/>
           <p:cNvSpPr txBox="1"/>
           <p:nvPr/>
         </p:nvSpPr>
         <p:spPr>
           <a:xfrm>
-            <a:off x="3054096" y="2139696"/>
-            <a:ext cx="1554480" cy="237744"/>
+            <a:off x="3054096" y="2048256"/>
+            <a:ext cx="1700784" cy="1234440"/>
           </a:xfrm>
           <a:prstGeom prst="rect">
             <a:avLst/>
@@ -4920,29 +5084,113 @@
           </a:bodyPr>
           <a:lstStyle/>
           <a:p>
+            <a:pPr algn="l">
+              <a:lnSpc>
+                <a:spcPct val="112000"/>
+              </a:lnSpc>
+            </a:pPr>
+            <a:r>
+              <a:rPr sz="1150" b="0">
+                <a:solidFill>
+                  <a:srgbClr val="18212B"/>
+                </a:solidFill>
+                <a:latin typeface="Malgun Gothic"/>
+              </a:rPr>
+              <a:t>Turn that FASTA into files searchable in milliseconds, and cluster it into families.</a:t>
+            </a:r>
+          </a:p>
+        </p:txBody>
+      </p:sp>
+      <p:cxnSp>
+        <p:nvCxnSpPr>
+          <p:cNvPr id="16" name="Connector 15"/>
+          <p:cNvCxnSpPr/>
+          <p:nvPr/>
+        </p:nvCxnSpPr>
+        <p:spPr>
+          <a:xfrm>
+            <a:off x="3054096" y="3310128"/>
+            <a:ext cx="1682496" cy="0"/>
+          </a:xfrm>
+          <a:prstGeom prst="line">
+            <a:avLst/>
+          </a:prstGeom>
+          <a:ln w="12700">
+            <a:solidFill>
+              <a:srgbClr val="D9DEE7"/>
+            </a:solidFill>
+          </a:ln>
+        </p:spPr>
+        <p:style>
+          <a:lnRef idx="2">
+            <a:schemeClr val="accent1"/>
+          </a:lnRef>
+          <a:fillRef idx="0">
+            <a:schemeClr val="accent1"/>
+          </a:fillRef>
+          <a:effectRef idx="1">
+            <a:schemeClr val="accent1"/>
+          </a:effectRef>
+          <a:fontRef idx="minor">
+            <a:schemeClr val="tx1"/>
+          </a:fontRef>
+        </p:style>
+      </p:cxnSp>
+      <p:sp>
+        <p:nvSpPr>
+          <p:cNvPr id="17" name="TextBox 16"/>
+          <p:cNvSpPr txBox="1"/>
+          <p:nvPr/>
+        </p:nvSpPr>
+        <p:spPr>
+          <a:xfrm>
+            <a:off x="3054096" y="3401568"/>
+            <a:ext cx="1737360" cy="457200"/>
+          </a:xfrm>
+          <a:prstGeom prst="rect">
+            <a:avLst/>
+          </a:prstGeom>
+          <a:noFill/>
+        </p:spPr>
+        <p:txBody>
+          <a:bodyPr wrap="square" lIns="0" rIns="0" tIns="0" bIns="0" anchor="t">
+            <a:noAutofit/>
+          </a:bodyPr>
+          <a:lstStyle/>
+          <a:p>
             <a:pPr algn="l"/>
             <a:r>
-              <a:rPr sz="1050" b="0">
+              <a:rPr sz="950" b="0">
                 <a:solidFill>
                   <a:srgbClr val="667085"/>
                 </a:solidFill>
-                <a:latin typeface="Malgun Gothic"/>
-              </a:rPr>
-              <a:t>FASTA + indexes</a:t>
-            </a:r>
-          </a:p>
-        </p:txBody>
-      </p:sp>
-      <p:sp>
-        <p:nvSpPr>
-          <p:cNvPr id="12" name="Right Arrow 11"/>
+                <a:latin typeface="Consolas"/>
+              </a:rPr>
+              <a:t>makeblastdb, MMseqs2,</a:t>
+            </a:r>
+            <a:br/>
+            <a:r>
+              <a:rPr sz="950" b="0">
+                <a:solidFill>
+                  <a:srgbClr val="667085"/>
+                </a:solidFill>
+                <a:latin typeface="Consolas"/>
+              </a:rPr>
+              <a:t>MAFFT, hmmbuild</a:t>
+            </a:r>
+          </a:p>
+        </p:txBody>
+      </p:sp>
+      <p:sp>
+        <p:nvSpPr>
+          <p:cNvPr id="18" name="Right Arrow 17"/>
           <p:cNvSpPr/>
           <p:nvPr/>
         </p:nvSpPr>
         <p:spPr>
           <a:xfrm>
-            <a:off x="4809744" y="1938528"/>
-            <a:ext cx="219456" cy="292608"/>
+            <a:off x="4942331" y="2596896"/>
+            <a:ext cx="137160" cy="219456"/>
           </a:xfrm>
           <a:prstGeom prst="rightArrow">
             <a:avLst/>
@@ -4980,14 +5228,14 @@
       </p:sp>
       <p:sp>
         <p:nvSpPr>
-          <p:cNvPr id="13" name="Rounded Rectangle 12"/>
+          <p:cNvPr id="19" name="Rounded Rectangle 18"/>
           <p:cNvSpPr/>
           <p:nvPr/>
         </p:nvSpPr>
         <p:spPr>
           <a:xfrm>
-            <a:off x="5084064" y="1600200"/>
-            <a:ext cx="1874519" cy="960120"/>
+            <a:off x="5084064" y="1481328"/>
+            <a:ext cx="2048256" cy="2487168"/>
           </a:xfrm>
           <a:prstGeom prst="roundRect">
             <a:avLst/>
@@ -5025,14 +5273,59 @@
       </p:sp>
       <p:sp>
         <p:nvSpPr>
-          <p:cNvPr id="14" name="TextBox 13"/>
+          <p:cNvPr id="20" name="Rectangle 19"/>
+          <p:cNvSpPr/>
+          <p:nvPr/>
+        </p:nvSpPr>
+        <p:spPr>
+          <a:xfrm>
+            <a:off x="5084064" y="1481328"/>
+            <a:ext cx="2048256" cy="420624"/>
+          </a:xfrm>
+          <a:prstGeom prst="rect">
+            <a:avLst/>
+          </a:prstGeom>
+          <a:solidFill>
+            <a:srgbClr val="176B87"/>
+          </a:solidFill>
+          <a:ln>
+            <a:solidFill>
+              <a:srgbClr val="176B87"/>
+            </a:solidFill>
+          </a:ln>
+        </p:spPr>
+        <p:style>
+          <a:lnRef idx="1">
+            <a:schemeClr val="accent1"/>
+          </a:lnRef>
+          <a:fillRef idx="3">
+            <a:schemeClr val="accent1"/>
+          </a:fillRef>
+          <a:effectRef idx="2">
+            <a:schemeClr val="accent1"/>
+          </a:effectRef>
+          <a:fontRef idx="minor">
+            <a:schemeClr val="lt1"/>
+          </a:fontRef>
+        </p:style>
+        <p:txBody>
+          <a:bodyPr rtlCol="0" anchor="ctr"/>
+          <a:lstStyle/>
+          <a:p>
+            <a:pPr algn="ctr"/>
+          </a:p>
+        </p:txBody>
+      </p:sp>
+      <p:sp>
+        <p:nvSpPr>
+          <p:cNvPr id="21" name="TextBox 20"/>
           <p:cNvSpPr txBox="1"/>
           <p:nvPr/>
         </p:nvSpPr>
         <p:spPr>
           <a:xfrm>
-            <a:off x="5266944" y="1810512"/>
-            <a:ext cx="1554480" cy="274320"/>
+            <a:off x="5266944" y="1572768"/>
+            <a:ext cx="1737360" cy="256032"/>
           </a:xfrm>
           <a:prstGeom prst="rect">
             <a:avLst/>
@@ -5047,27 +5340,27 @@
           <a:p>
             <a:pPr algn="l"/>
             <a:r>
-              <a:rPr sz="1350" b="1">
-                <a:solidFill>
-                  <a:srgbClr val="18212B"/>
-                </a:solidFill>
-                <a:latin typeface="Malgun Gothic"/>
-              </a:rPr>
-              <a:t>Sequence in</a:t>
-            </a:r>
-          </a:p>
-        </p:txBody>
-      </p:sp>
-      <p:sp>
-        <p:nvSpPr>
-          <p:cNvPr id="15" name="TextBox 14"/>
+              <a:rPr sz="1400" b="1">
+                <a:solidFill>
+                  <a:srgbClr val="FFFFFF"/>
+                </a:solidFill>
+                <a:latin typeface="Malgun Gothic"/>
+              </a:rPr>
+              <a:t>3   Submit</a:t>
+            </a:r>
+          </a:p>
+        </p:txBody>
+      </p:sp>
+      <p:sp>
+        <p:nvSpPr>
+          <p:cNvPr id="22" name="TextBox 21"/>
           <p:cNvSpPr txBox="1"/>
           <p:nvPr/>
         </p:nvSpPr>
         <p:spPr>
           <a:xfrm>
-            <a:off x="5266944" y="2139696"/>
-            <a:ext cx="1554480" cy="237744"/>
+            <a:off x="5266944" y="2048256"/>
+            <a:ext cx="1700784" cy="1234440"/>
           </a:xfrm>
           <a:prstGeom prst="rect">
             <a:avLst/>
@@ -5080,29 +5373,103 @@
           </a:bodyPr>
           <a:lstStyle/>
           <a:p>
+            <a:pPr algn="l">
+              <a:lnSpc>
+                <a:spcPct val="112000"/>
+              </a:lnSpc>
+            </a:pPr>
+            <a:r>
+              <a:rPr sz="1150" b="0">
+                <a:solidFill>
+                  <a:srgbClr val="18212B"/>
+                </a:solidFill>
+                <a:latin typeface="Malgun Gothic"/>
+              </a:rPr>
+              <a:t>A user pastes a sequence. It is parsed and checked before anything runs.</a:t>
+            </a:r>
+          </a:p>
+        </p:txBody>
+      </p:sp>
+      <p:cxnSp>
+        <p:nvCxnSpPr>
+          <p:cNvPr id="23" name="Connector 22"/>
+          <p:cNvCxnSpPr/>
+          <p:nvPr/>
+        </p:nvCxnSpPr>
+        <p:spPr>
+          <a:xfrm>
+            <a:off x="5266944" y="3310128"/>
+            <a:ext cx="1682496" cy="0"/>
+          </a:xfrm>
+          <a:prstGeom prst="line">
+            <a:avLst/>
+          </a:prstGeom>
+          <a:ln w="12700">
+            <a:solidFill>
+              <a:srgbClr val="D9DEE7"/>
+            </a:solidFill>
+          </a:ln>
+        </p:spPr>
+        <p:style>
+          <a:lnRef idx="2">
+            <a:schemeClr val="accent1"/>
+          </a:lnRef>
+          <a:fillRef idx="0">
+            <a:schemeClr val="accent1"/>
+          </a:fillRef>
+          <a:effectRef idx="1">
+            <a:schemeClr val="accent1"/>
+          </a:effectRef>
+          <a:fontRef idx="minor">
+            <a:schemeClr val="tx1"/>
+          </a:fontRef>
+        </p:style>
+      </p:cxnSp>
+      <p:sp>
+        <p:nvSpPr>
+          <p:cNvPr id="24" name="TextBox 23"/>
+          <p:cNvSpPr txBox="1"/>
+          <p:nvPr/>
+        </p:nvSpPr>
+        <p:spPr>
+          <a:xfrm>
+            <a:off x="5266944" y="3401568"/>
+            <a:ext cx="1737360" cy="457200"/>
+          </a:xfrm>
+          <a:prstGeom prst="rect">
+            <a:avLst/>
+          </a:prstGeom>
+          <a:noFill/>
+        </p:spPr>
+        <p:txBody>
+          <a:bodyPr wrap="square" lIns="0" rIns="0" tIns="0" bIns="0" anchor="t">
+            <a:noAutofit/>
+          </a:bodyPr>
+          <a:lstStyle/>
+          <a:p>
             <a:pPr algn="l"/>
             <a:r>
-              <a:rPr sz="1050" b="0">
+              <a:rPr sz="950" b="0">
                 <a:solidFill>
                   <a:srgbClr val="667085"/>
                 </a:solidFill>
-                <a:latin typeface="Malgun Gothic"/>
-              </a:rPr>
-              <a:t>web form</a:t>
-            </a:r>
-          </a:p>
-        </p:txBody>
-      </p:sp>
-      <p:sp>
-        <p:nvSpPr>
-          <p:cNvPr id="16" name="Right Arrow 15"/>
+                <a:latin typeface="Consolas"/>
+              </a:rPr>
+              <a:t>web form  -&gt;  FASTA</a:t>
+            </a:r>
+          </a:p>
+        </p:txBody>
+      </p:sp>
+      <p:sp>
+        <p:nvSpPr>
+          <p:cNvPr id="25" name="Right Arrow 24"/>
           <p:cNvSpPr/>
           <p:nvPr/>
         </p:nvSpPr>
         <p:spPr>
           <a:xfrm>
-            <a:off x="7022592" y="1938528"/>
-            <a:ext cx="219456" cy="292608"/>
+            <a:off x="7155179" y="2596896"/>
+            <a:ext cx="137160" cy="219456"/>
           </a:xfrm>
           <a:prstGeom prst="rightArrow">
             <a:avLst/>
@@ -5140,14 +5507,14 @@
       </p:sp>
       <p:sp>
         <p:nvSpPr>
-          <p:cNvPr id="17" name="Rounded Rectangle 16"/>
+          <p:cNvPr id="26" name="Rounded Rectangle 25"/>
           <p:cNvSpPr/>
           <p:nvPr/>
         </p:nvSpPr>
         <p:spPr>
           <a:xfrm>
-            <a:off x="7296912" y="1600200"/>
-            <a:ext cx="1874519" cy="960120"/>
+            <a:off x="7296912" y="1481328"/>
+            <a:ext cx="2048256" cy="2487168"/>
           </a:xfrm>
           <a:prstGeom prst="roundRect">
             <a:avLst/>
@@ -5185,14 +5552,59 @@
       </p:sp>
       <p:sp>
         <p:nvSpPr>
-          <p:cNvPr id="18" name="TextBox 17"/>
+          <p:cNvPr id="27" name="Rectangle 26"/>
+          <p:cNvSpPr/>
+          <p:nvPr/>
+        </p:nvSpPr>
+        <p:spPr>
+          <a:xfrm>
+            <a:off x="7296912" y="1481328"/>
+            <a:ext cx="2048256" cy="420624"/>
+          </a:xfrm>
+          <a:prstGeom prst="rect">
+            <a:avLst/>
+          </a:prstGeom>
+          <a:solidFill>
+            <a:srgbClr val="176B87"/>
+          </a:solidFill>
+          <a:ln>
+            <a:solidFill>
+              <a:srgbClr val="176B87"/>
+            </a:solidFill>
+          </a:ln>
+        </p:spPr>
+        <p:style>
+          <a:lnRef idx="1">
+            <a:schemeClr val="accent1"/>
+          </a:lnRef>
+          <a:fillRef idx="3">
+            <a:schemeClr val="accent1"/>
+          </a:fillRef>
+          <a:effectRef idx="2">
+            <a:schemeClr val="accent1"/>
+          </a:effectRef>
+          <a:fontRef idx="minor">
+            <a:schemeClr val="lt1"/>
+          </a:fontRef>
+        </p:style>
+        <p:txBody>
+          <a:bodyPr rtlCol="0" anchor="ctr"/>
+          <a:lstStyle/>
+          <a:p>
+            <a:pPr algn="ctr"/>
+          </a:p>
+        </p:txBody>
+      </p:sp>
+      <p:sp>
+        <p:nvSpPr>
+          <p:cNvPr id="28" name="TextBox 27"/>
           <p:cNvSpPr txBox="1"/>
           <p:nvPr/>
         </p:nvSpPr>
         <p:spPr>
           <a:xfrm>
-            <a:off x="7479792" y="1810512"/>
-            <a:ext cx="1554480" cy="274320"/>
+            <a:off x="7479792" y="1572768"/>
+            <a:ext cx="1737360" cy="256032"/>
           </a:xfrm>
           <a:prstGeom prst="rect">
             <a:avLst/>
@@ -5207,27 +5619,27 @@
           <a:p>
             <a:pPr algn="l"/>
             <a:r>
-              <a:rPr sz="1350" b="1">
-                <a:solidFill>
-                  <a:srgbClr val="18212B"/>
-                </a:solidFill>
-                <a:latin typeface="Malgun Gothic"/>
-              </a:rPr>
-              <a:t>Three searches</a:t>
-            </a:r>
-          </a:p>
-        </p:txBody>
-      </p:sp>
-      <p:sp>
-        <p:nvSpPr>
-          <p:cNvPr id="19" name="TextBox 18"/>
+              <a:rPr sz="1400" b="1">
+                <a:solidFill>
+                  <a:srgbClr val="FFFFFF"/>
+                </a:solidFill>
+                <a:latin typeface="Malgun Gothic"/>
+              </a:rPr>
+              <a:t>4   Search</a:t>
+            </a:r>
+          </a:p>
+        </p:txBody>
+      </p:sp>
+      <p:sp>
+        <p:nvSpPr>
+          <p:cNvPr id="29" name="TextBox 28"/>
           <p:cNvSpPr txBox="1"/>
           <p:nvPr/>
         </p:nvSpPr>
         <p:spPr>
           <a:xfrm>
-            <a:off x="7479792" y="2139696"/>
-            <a:ext cx="1554480" cy="237744"/>
+            <a:off x="7479792" y="2048256"/>
+            <a:ext cx="1700784" cy="1234440"/>
           </a:xfrm>
           <a:prstGeom prst="rect">
             <a:avLst/>
@@ -5240,29 +5652,103 @@
           </a:bodyPr>
           <a:lstStyle/>
           <a:p>
+            <a:pPr algn="l">
+              <a:lnSpc>
+                <a:spcPct val="112000"/>
+              </a:lnSpc>
+            </a:pPr>
+            <a:r>
+              <a:rPr sz="1150" b="0">
+                <a:solidFill>
+                  <a:srgbClr val="18212B"/>
+                </a:solidFill>
+                <a:latin typeface="Malgun Gothic"/>
+              </a:rPr>
+              <a:t>All three searches run against the built files. No database is touched.</a:t>
+            </a:r>
+          </a:p>
+        </p:txBody>
+      </p:sp>
+      <p:cxnSp>
+        <p:nvCxnSpPr>
+          <p:cNvPr id="30" name="Connector 29"/>
+          <p:cNvCxnSpPr/>
+          <p:nvPr/>
+        </p:nvCxnSpPr>
+        <p:spPr>
+          <a:xfrm>
+            <a:off x="7479792" y="3310128"/>
+            <a:ext cx="1682496" cy="0"/>
+          </a:xfrm>
+          <a:prstGeom prst="line">
+            <a:avLst/>
+          </a:prstGeom>
+          <a:ln w="12700">
+            <a:solidFill>
+              <a:srgbClr val="D9DEE7"/>
+            </a:solidFill>
+          </a:ln>
+        </p:spPr>
+        <p:style>
+          <a:lnRef idx="2">
+            <a:schemeClr val="accent1"/>
+          </a:lnRef>
+          <a:fillRef idx="0">
+            <a:schemeClr val="accent1"/>
+          </a:fillRef>
+          <a:effectRef idx="1">
+            <a:schemeClr val="accent1"/>
+          </a:effectRef>
+          <a:fontRef idx="minor">
+            <a:schemeClr val="tx1"/>
+          </a:fontRef>
+        </p:style>
+      </p:cxnSp>
+      <p:sp>
+        <p:nvSpPr>
+          <p:cNvPr id="31" name="TextBox 30"/>
+          <p:cNvSpPr txBox="1"/>
+          <p:nvPr/>
+        </p:nvSpPr>
+        <p:spPr>
+          <a:xfrm>
+            <a:off x="7479792" y="3401568"/>
+            <a:ext cx="1737360" cy="457200"/>
+          </a:xfrm>
+          <a:prstGeom prst="rect">
+            <a:avLst/>
+          </a:prstGeom>
+          <a:noFill/>
+        </p:spPr>
+        <p:txBody>
+          <a:bodyPr wrap="square" lIns="0" rIns="0" tIns="0" bIns="0" anchor="t">
+            <a:noAutofit/>
+          </a:bodyPr>
+          <a:lstStyle/>
+          <a:p>
             <a:pPr algn="l"/>
             <a:r>
-              <a:rPr sz="1050" b="0">
+              <a:rPr sz="950" b="0">
                 <a:solidFill>
                   <a:srgbClr val="667085"/>
                 </a:solidFill>
-                <a:latin typeface="Malgun Gothic"/>
-              </a:rPr>
-              <a:t>BLAST + HMMER</a:t>
-            </a:r>
-          </a:p>
-        </p:txBody>
-      </p:sp>
-      <p:sp>
-        <p:nvSpPr>
-          <p:cNvPr id="20" name="Right Arrow 19"/>
+                <a:latin typeface="Consolas"/>
+              </a:rPr>
+              <a:t>blastp, phmmer, hmmscan</a:t>
+            </a:r>
+          </a:p>
+        </p:txBody>
+      </p:sp>
+      <p:sp>
+        <p:nvSpPr>
+          <p:cNvPr id="32" name="Right Arrow 31"/>
           <p:cNvSpPr/>
           <p:nvPr/>
         </p:nvSpPr>
         <p:spPr>
           <a:xfrm>
-            <a:off x="9235440" y="1938528"/>
-            <a:ext cx="219456" cy="292608"/>
+            <a:off x="9368028" y="2596896"/>
+            <a:ext cx="137160" cy="219456"/>
           </a:xfrm>
           <a:prstGeom prst="rightArrow">
             <a:avLst/>
@@ -5300,14 +5786,14 @@
       </p:sp>
       <p:sp>
         <p:nvSpPr>
-          <p:cNvPr id="21" name="Rounded Rectangle 20"/>
+          <p:cNvPr id="33" name="Rounded Rectangle 32"/>
           <p:cNvSpPr/>
           <p:nvPr/>
         </p:nvSpPr>
         <p:spPr>
           <a:xfrm>
-            <a:off x="9509760" y="1600200"/>
-            <a:ext cx="1874519" cy="960120"/>
+            <a:off x="9509760" y="1481328"/>
+            <a:ext cx="2048256" cy="2487168"/>
           </a:xfrm>
           <a:prstGeom prst="roundRect">
             <a:avLst/>
@@ -5345,14 +5831,59 @@
       </p:sp>
       <p:sp>
         <p:nvSpPr>
-          <p:cNvPr id="22" name="TextBox 21"/>
+          <p:cNvPr id="34" name="Rectangle 33"/>
+          <p:cNvSpPr/>
+          <p:nvPr/>
+        </p:nvSpPr>
+        <p:spPr>
+          <a:xfrm>
+            <a:off x="9509760" y="1481328"/>
+            <a:ext cx="2048256" cy="420624"/>
+          </a:xfrm>
+          <a:prstGeom prst="rect">
+            <a:avLst/>
+          </a:prstGeom>
+          <a:solidFill>
+            <a:srgbClr val="176B87"/>
+          </a:solidFill>
+          <a:ln>
+            <a:solidFill>
+              <a:srgbClr val="176B87"/>
+            </a:solidFill>
+          </a:ln>
+        </p:spPr>
+        <p:style>
+          <a:lnRef idx="1">
+            <a:schemeClr val="accent1"/>
+          </a:lnRef>
+          <a:fillRef idx="3">
+            <a:schemeClr val="accent1"/>
+          </a:fillRef>
+          <a:effectRef idx="2">
+            <a:schemeClr val="accent1"/>
+          </a:effectRef>
+          <a:fontRef idx="minor">
+            <a:schemeClr val="lt1"/>
+          </a:fontRef>
+        </p:style>
+        <p:txBody>
+          <a:bodyPr rtlCol="0" anchor="ctr"/>
+          <a:lstStyle/>
+          <a:p>
+            <a:pPr algn="ctr"/>
+          </a:p>
+        </p:txBody>
+      </p:sp>
+      <p:sp>
+        <p:nvSpPr>
+          <p:cNvPr id="35" name="TextBox 34"/>
           <p:cNvSpPr txBox="1"/>
           <p:nvPr/>
         </p:nvSpPr>
         <p:spPr>
           <a:xfrm>
-            <a:off x="9692640" y="1810512"/>
-            <a:ext cx="1554480" cy="274320"/>
+            <a:off x="9692640" y="1572768"/>
+            <a:ext cx="1737360" cy="256032"/>
           </a:xfrm>
           <a:prstGeom prst="rect">
             <a:avLst/>
@@ -5367,27 +5898,27 @@
           <a:p>
             <a:pPr algn="l"/>
             <a:r>
-              <a:rPr sz="1350" b="1">
-                <a:solidFill>
-                  <a:srgbClr val="18212B"/>
-                </a:solidFill>
-                <a:latin typeface="Malgun Gothic"/>
-              </a:rPr>
-              <a:t>Result page</a:t>
-            </a:r>
-          </a:p>
-        </p:txBody>
-      </p:sp>
-      <p:sp>
-        <p:nvSpPr>
-          <p:cNvPr id="23" name="TextBox 22"/>
+              <a:rPr sz="1400" b="1">
+                <a:solidFill>
+                  <a:srgbClr val="FFFFFF"/>
+                </a:solidFill>
+                <a:latin typeface="Malgun Gothic"/>
+              </a:rPr>
+              <a:t>5   Show</a:t>
+            </a:r>
+          </a:p>
+        </p:txBody>
+      </p:sp>
+      <p:sp>
+        <p:nvSpPr>
+          <p:cNvPr id="36" name="TextBox 35"/>
           <p:cNvSpPr txBox="1"/>
           <p:nvPr/>
         </p:nvSpPr>
         <p:spPr>
           <a:xfrm>
-            <a:off x="9692640" y="2139696"/>
-            <a:ext cx="1554480" cy="237744"/>
+            <a:off x="9692640" y="2048256"/>
+            <a:ext cx="1700784" cy="1234440"/>
           </a:xfrm>
           <a:prstGeom prst="rect">
             <a:avLst/>
@@ -5400,29 +5931,403 @@
           </a:bodyPr>
           <a:lstStyle/>
           <a:p>
+            <a:pPr algn="l">
+              <a:lnSpc>
+                <a:spcPct val="112000"/>
+              </a:lnSpc>
+            </a:pPr>
+            <a:r>
+              <a:rPr sz="1150" b="0">
+                <a:solidFill>
+                  <a:srgbClr val="18212B"/>
+                </a:solidFill>
+                <a:latin typeface="Malgun Gothic"/>
+              </a:rPr>
+              <a:t>Attach EC, source and description to each hit, then render the tables.</a:t>
+            </a:r>
+          </a:p>
+        </p:txBody>
+      </p:sp>
+      <p:cxnSp>
+        <p:nvCxnSpPr>
+          <p:cNvPr id="37" name="Connector 36"/>
+          <p:cNvCxnSpPr/>
+          <p:nvPr/>
+        </p:nvCxnSpPr>
+        <p:spPr>
+          <a:xfrm>
+            <a:off x="9692640" y="3310128"/>
+            <a:ext cx="1682496" cy="0"/>
+          </a:xfrm>
+          <a:prstGeom prst="line">
+            <a:avLst/>
+          </a:prstGeom>
+          <a:ln w="12700">
+            <a:solidFill>
+              <a:srgbClr val="D9DEE7"/>
+            </a:solidFill>
+          </a:ln>
+        </p:spPr>
+        <p:style>
+          <a:lnRef idx="2">
+            <a:schemeClr val="accent1"/>
+          </a:lnRef>
+          <a:fillRef idx="0">
+            <a:schemeClr val="accent1"/>
+          </a:fillRef>
+          <a:effectRef idx="1">
+            <a:schemeClr val="accent1"/>
+          </a:effectRef>
+          <a:fontRef idx="minor">
+            <a:schemeClr val="tx1"/>
+          </a:fontRef>
+        </p:style>
+      </p:cxnSp>
+      <p:sp>
+        <p:nvSpPr>
+          <p:cNvPr id="38" name="TextBox 37"/>
+          <p:cNvSpPr txBox="1"/>
+          <p:nvPr/>
+        </p:nvSpPr>
+        <p:spPr>
+          <a:xfrm>
+            <a:off x="9692640" y="3401568"/>
+            <a:ext cx="1737360" cy="457200"/>
+          </a:xfrm>
+          <a:prstGeom prst="rect">
+            <a:avLst/>
+          </a:prstGeom>
+          <a:noFill/>
+        </p:spPr>
+        <p:txBody>
+          <a:bodyPr wrap="square" lIns="0" rIns="0" tIns="0" bIns="0" anchor="t">
+            <a:noAutofit/>
+          </a:bodyPr>
+          <a:lstStyle/>
+          <a:p>
             <a:pPr algn="l"/>
             <a:r>
-              <a:rPr sz="1050" b="0">
+              <a:rPr sz="950" b="0">
                 <a:solidFill>
                   <a:srgbClr val="667085"/>
                 </a:solidFill>
-                <a:latin typeface="Malgun Gothic"/>
-              </a:rPr>
-              <a:t>HTML, CSV, JSON</a:t>
-            </a:r>
-          </a:p>
-        </p:txBody>
-      </p:sp>
-      <p:sp>
-        <p:nvSpPr>
-          <p:cNvPr id="24" name="Rounded Rectangle 23"/>
+                <a:latin typeface="Consolas"/>
+              </a:rPr>
+              <a:t>SQLite  -&gt;  HTML, CSV, JSON</a:t>
+            </a:r>
+          </a:p>
+        </p:txBody>
+      </p:sp>
+      <p:sp>
+        <p:nvSpPr>
+          <p:cNvPr id="39" name="Rounded Rectangle 38"/>
           <p:cNvSpPr/>
           <p:nvPr/>
         </p:nvSpPr>
         <p:spPr>
           <a:xfrm>
-            <a:off x="658368" y="3017520"/>
-            <a:ext cx="3474720" cy="2240280"/>
+            <a:off x="658368" y="4169663"/>
+            <a:ext cx="4261104" cy="1170432"/>
+          </a:xfrm>
+          <a:prstGeom prst="roundRect">
+            <a:avLst/>
+          </a:prstGeom>
+          <a:solidFill>
+            <a:srgbClr val="FBECEC"/>
+          </a:solidFill>
+          <a:ln w="12700">
+            <a:solidFill>
+              <a:srgbClr val="FBECEC"/>
+            </a:solidFill>
+          </a:ln>
+        </p:spPr>
+        <p:style>
+          <a:lnRef idx="1">
+            <a:schemeClr val="accent1"/>
+          </a:lnRef>
+          <a:fillRef idx="3">
+            <a:schemeClr val="accent1"/>
+          </a:fillRef>
+          <a:effectRef idx="2">
+            <a:schemeClr val="accent1"/>
+          </a:effectRef>
+          <a:fontRef idx="minor">
+            <a:schemeClr val="lt1"/>
+          </a:fontRef>
+        </p:style>
+        <p:txBody>
+          <a:bodyPr rtlCol="0" anchor="ctr"/>
+          <a:lstStyle/>
+          <a:p>
+            <a:pPr algn="ctr"/>
+          </a:p>
+        </p:txBody>
+      </p:sp>
+      <p:sp>
+        <p:nvSpPr>
+          <p:cNvPr id="40" name="TextBox 39"/>
+          <p:cNvSpPr txBox="1"/>
+          <p:nvPr/>
+        </p:nvSpPr>
+        <p:spPr>
+          <a:xfrm>
+            <a:off x="932688" y="4352544"/>
+            <a:ext cx="1828800" cy="292608"/>
+          </a:xfrm>
+          <a:prstGeom prst="rect">
+            <a:avLst/>
+          </a:prstGeom>
+          <a:noFill/>
+        </p:spPr>
+        <p:txBody>
+          <a:bodyPr wrap="square" lIns="0" rIns="0" tIns="0" bIns="0" anchor="t">
+            <a:noAutofit/>
+          </a:bodyPr>
+          <a:lstStyle/>
+          <a:p>
+            <a:pPr algn="l"/>
+            <a:r>
+              <a:rPr sz="1500" b="1">
+                <a:solidFill>
+                  <a:srgbClr val="B71A1A"/>
+                </a:solidFill>
+                <a:latin typeface="Malgun Gothic"/>
+              </a:rPr>
+              <a:t>OFFLINE</a:t>
+            </a:r>
+          </a:p>
+        </p:txBody>
+      </p:sp>
+      <p:sp>
+        <p:nvSpPr>
+          <p:cNvPr id="41" name="TextBox 40"/>
+          <p:cNvSpPr txBox="1"/>
+          <p:nvPr/>
+        </p:nvSpPr>
+        <p:spPr>
+          <a:xfrm>
+            <a:off x="3547872" y="4370832"/>
+            <a:ext cx="1097280" cy="256032"/>
+          </a:xfrm>
+          <a:prstGeom prst="rect">
+            <a:avLst/>
+          </a:prstGeom>
+          <a:noFill/>
+        </p:spPr>
+        <p:txBody>
+          <a:bodyPr wrap="square" lIns="0" rIns="0" tIns="0" bIns="0" anchor="t">
+            <a:noAutofit/>
+          </a:bodyPr>
+          <a:lstStyle/>
+          <a:p>
+            <a:pPr algn="r"/>
+            <a:r>
+              <a:rPr sz="1300" b="1">
+                <a:solidFill>
+                  <a:srgbClr val="B71A1A"/>
+                </a:solidFill>
+                <a:latin typeface="Malgun Gothic"/>
+              </a:rPr>
+              <a:t>minutes</a:t>
+            </a:r>
+          </a:p>
+        </p:txBody>
+      </p:sp>
+      <p:sp>
+        <p:nvSpPr>
+          <p:cNvPr id="42" name="TextBox 41"/>
+          <p:cNvSpPr txBox="1"/>
+          <p:nvPr/>
+        </p:nvSpPr>
+        <p:spPr>
+          <a:xfrm>
+            <a:off x="932688" y="4754880"/>
+            <a:ext cx="3712464" cy="384048"/>
+          </a:xfrm>
+          <a:prstGeom prst="rect">
+            <a:avLst/>
+          </a:prstGeom>
+          <a:noFill/>
+        </p:spPr>
+        <p:txBody>
+          <a:bodyPr wrap="square" lIns="0" rIns="0" tIns="0" bIns="0" anchor="t">
+            <a:noAutofit/>
+          </a:bodyPr>
+          <a:lstStyle/>
+          <a:p>
+            <a:pPr algn="l"/>
+            <a:r>
+              <a:rPr sz="1300" b="0">
+                <a:solidFill>
+                  <a:srgbClr val="18212B"/>
+                </a:solidFill>
+                <a:latin typeface="Malgun Gothic"/>
+              </a:rPr>
+              <a:t>Runs on a schedule after each database refresh</a:t>
+            </a:r>
+          </a:p>
+        </p:txBody>
+      </p:sp>
+      <p:sp>
+        <p:nvSpPr>
+          <p:cNvPr id="43" name="Rounded Rectangle 42"/>
+          <p:cNvSpPr/>
+          <p:nvPr/>
+        </p:nvSpPr>
+        <p:spPr>
+          <a:xfrm>
+            <a:off x="5084064" y="4169663"/>
+            <a:ext cx="6455664" cy="1170432"/>
+          </a:xfrm>
+          <a:prstGeom prst="roundRect">
+            <a:avLst/>
+          </a:prstGeom>
+          <a:solidFill>
+            <a:srgbClr val="EAF4F7"/>
+          </a:solidFill>
+          <a:ln w="12700">
+            <a:solidFill>
+              <a:srgbClr val="EAF4F7"/>
+            </a:solidFill>
+          </a:ln>
+        </p:spPr>
+        <p:style>
+          <a:lnRef idx="1">
+            <a:schemeClr val="accent1"/>
+          </a:lnRef>
+          <a:fillRef idx="3">
+            <a:schemeClr val="accent1"/>
+          </a:fillRef>
+          <a:effectRef idx="2">
+            <a:schemeClr val="accent1"/>
+          </a:effectRef>
+          <a:fontRef idx="minor">
+            <a:schemeClr val="lt1"/>
+          </a:fontRef>
+        </p:style>
+        <p:txBody>
+          <a:bodyPr rtlCol="0" anchor="ctr"/>
+          <a:lstStyle/>
+          <a:p>
+            <a:pPr algn="ctr"/>
+          </a:p>
+        </p:txBody>
+      </p:sp>
+      <p:sp>
+        <p:nvSpPr>
+          <p:cNvPr id="44" name="TextBox 43"/>
+          <p:cNvSpPr txBox="1"/>
+          <p:nvPr/>
+        </p:nvSpPr>
+        <p:spPr>
+          <a:xfrm>
+            <a:off x="5358383" y="4352544"/>
+            <a:ext cx="1828800" cy="292608"/>
+          </a:xfrm>
+          <a:prstGeom prst="rect">
+            <a:avLst/>
+          </a:prstGeom>
+          <a:noFill/>
+        </p:spPr>
+        <p:txBody>
+          <a:bodyPr wrap="square" lIns="0" rIns="0" tIns="0" bIns="0" anchor="t">
+            <a:noAutofit/>
+          </a:bodyPr>
+          <a:lstStyle/>
+          <a:p>
+            <a:pPr algn="l"/>
+            <a:r>
+              <a:rPr sz="1500" b="1">
+                <a:solidFill>
+                  <a:srgbClr val="176B87"/>
+                </a:solidFill>
+                <a:latin typeface="Malgun Gothic"/>
+              </a:rPr>
+              <a:t>ONLINE</a:t>
+            </a:r>
+          </a:p>
+        </p:txBody>
+      </p:sp>
+      <p:sp>
+        <p:nvSpPr>
+          <p:cNvPr id="45" name="TextBox 44"/>
+          <p:cNvSpPr txBox="1"/>
+          <p:nvPr/>
+        </p:nvSpPr>
+        <p:spPr>
+          <a:xfrm>
+            <a:off x="10168128" y="4370832"/>
+            <a:ext cx="1097280" cy="256032"/>
+          </a:xfrm>
+          <a:prstGeom prst="rect">
+            <a:avLst/>
+          </a:prstGeom>
+          <a:noFill/>
+        </p:spPr>
+        <p:txBody>
+          <a:bodyPr wrap="square" lIns="0" rIns="0" tIns="0" bIns="0" anchor="t">
+            <a:noAutofit/>
+          </a:bodyPr>
+          <a:lstStyle/>
+          <a:p>
+            <a:pPr algn="r"/>
+            <a:r>
+              <a:rPr sz="1300" b="1">
+                <a:solidFill>
+                  <a:srgbClr val="176B87"/>
+                </a:solidFill>
+                <a:latin typeface="Malgun Gothic"/>
+              </a:rPr>
+              <a:t>seconds</a:t>
+            </a:r>
+          </a:p>
+        </p:txBody>
+      </p:sp>
+      <p:sp>
+        <p:nvSpPr>
+          <p:cNvPr id="46" name="TextBox 45"/>
+          <p:cNvSpPr txBox="1"/>
+          <p:nvPr/>
+        </p:nvSpPr>
+        <p:spPr>
+          <a:xfrm>
+            <a:off x="5358383" y="4754880"/>
+            <a:ext cx="5907024" cy="384048"/>
+          </a:xfrm>
+          <a:prstGeom prst="rect">
+            <a:avLst/>
+          </a:prstGeom>
+          <a:noFill/>
+        </p:spPr>
+        <p:txBody>
+          <a:bodyPr wrap="square" lIns="0" rIns="0" tIns="0" bIns="0" anchor="t">
+            <a:noAutofit/>
+          </a:bodyPr>
+          <a:lstStyle/>
+          <a:p>
+            <a:pPr algn="l"/>
+            <a:r>
+              <a:rPr sz="1300" b="0">
+                <a:solidFill>
+                  <a:srgbClr val="18212B"/>
+                </a:solidFill>
+                <a:latin typeface="Malgun Gothic"/>
+              </a:rPr>
+              <a:t>Runs per user request, inside the existing job queue</a:t>
+            </a:r>
+          </a:p>
+        </p:txBody>
+      </p:sp>
+      <p:sp>
+        <p:nvSpPr>
+          <p:cNvPr id="47" name="Rounded Rectangle 46"/>
+          <p:cNvSpPr/>
+          <p:nvPr/>
+        </p:nvSpPr>
+        <p:spPr>
+          <a:xfrm>
+            <a:off x="658368" y="5577840"/>
+            <a:ext cx="10881360" cy="566928"/>
           </a:xfrm>
           <a:prstGeom prst="roundRect">
             <a:avLst/>
@@ -5460,59 +6365,14 @@
       </p:sp>
       <p:sp>
         <p:nvSpPr>
-          <p:cNvPr id="25" name="Rectangle 24"/>
-          <p:cNvSpPr/>
-          <p:nvPr/>
-        </p:nvSpPr>
-        <p:spPr>
-          <a:xfrm>
-            <a:off x="658368" y="3017520"/>
-            <a:ext cx="3474720" cy="100584"/>
-          </a:xfrm>
-          <a:prstGeom prst="rect">
-            <a:avLst/>
-          </a:prstGeom>
-          <a:solidFill>
-            <a:srgbClr val="B71A1A"/>
-          </a:solidFill>
-          <a:ln>
-            <a:solidFill>
-              <a:srgbClr val="B71A1A"/>
-            </a:solidFill>
-          </a:ln>
-        </p:spPr>
-        <p:style>
-          <a:lnRef idx="1">
-            <a:schemeClr val="accent1"/>
-          </a:lnRef>
-          <a:fillRef idx="3">
-            <a:schemeClr val="accent1"/>
-          </a:fillRef>
-          <a:effectRef idx="2">
-            <a:schemeClr val="accent1"/>
-          </a:effectRef>
-          <a:fontRef idx="minor">
-            <a:schemeClr val="lt1"/>
-          </a:fontRef>
-        </p:style>
-        <p:txBody>
-          <a:bodyPr rtlCol="0" anchor="ctr"/>
-          <a:lstStyle/>
-          <a:p>
-            <a:pPr algn="ctr"/>
-          </a:p>
-        </p:txBody>
-      </p:sp>
-      <p:sp>
-        <p:nvSpPr>
-          <p:cNvPr id="26" name="TextBox 25"/>
+          <p:cNvPr id="48" name="TextBox 47"/>
           <p:cNvSpPr txBox="1"/>
           <p:nvPr/>
         </p:nvSpPr>
         <p:spPr>
           <a:xfrm>
-            <a:off x="914400" y="3310128"/>
-            <a:ext cx="3017520" cy="329184"/>
+            <a:off x="658368" y="5742432"/>
+            <a:ext cx="10881360" cy="274320"/>
           </a:xfrm>
           <a:prstGeom prst="rect">
             <a:avLst/>
@@ -5525,505 +6385,15 @@
           </a:bodyPr>
           <a:lstStyle/>
           <a:p>
-            <a:pPr algn="l"/>
-            <a:r>
-              <a:rPr sz="1800" b="1">
-                <a:solidFill>
-                  <a:srgbClr val="B71A1A"/>
-                </a:solidFill>
-                <a:latin typeface="Malgun Gothic"/>
-              </a:rPr>
-              <a:t>Reference builder</a:t>
-            </a:r>
-          </a:p>
-        </p:txBody>
-      </p:sp>
-      <p:sp>
-        <p:nvSpPr>
-          <p:cNvPr id="27" name="TextBox 26"/>
-          <p:cNvSpPr txBox="1"/>
-          <p:nvPr/>
-        </p:nvSpPr>
-        <p:spPr>
-          <a:xfrm>
-            <a:off x="914400" y="3840480"/>
-            <a:ext cx="3017520" cy="1737360"/>
-          </a:xfrm>
-          <a:prstGeom prst="rect">
-            <a:avLst/>
-          </a:prstGeom>
-          <a:noFill/>
-        </p:spPr>
-        <p:txBody>
-          <a:bodyPr wrap="square" lIns="18288" rIns="18288" tIns="18288" bIns="18288">
-            <a:noAutofit/>
-          </a:bodyPr>
-          <a:lstStyle/>
-          <a:p>
-            <a:pPr>
-              <a:lnSpc>
-                <a:spcPct val="105000"/>
-              </a:lnSpc>
-              <a:spcAft>
-                <a:spcPts val="1000"/>
-              </a:spcAft>
-            </a:pPr>
-            <a:r>
-              <a:rPr sz="1350">
-                <a:solidFill>
-                  <a:srgbClr val="18212B"/>
-                </a:solidFill>
-                <a:latin typeface="Malgun Gothic"/>
-              </a:rPr>
-              <a:t>•  Reads the copied DB once</a:t>
-            </a:r>
-          </a:p>
-          <a:p>
-            <a:pPr>
-              <a:lnSpc>
-                <a:spcPct val="105000"/>
-              </a:lnSpc>
-              <a:spcAft>
-                <a:spcPts val="1000"/>
-              </a:spcAft>
-            </a:pPr>
-            <a:r>
-              <a:rPr sz="1350">
-                <a:solidFill>
-                  <a:srgbClr val="18212B"/>
-                </a:solidFill>
-                <a:latin typeface="Malgun Gothic"/>
-              </a:rPr>
-              <a:t>•  Swiss-Prot and PDB rows</a:t>
-            </a:r>
-          </a:p>
-          <a:p>
-            <a:pPr>
-              <a:lnSpc>
-                <a:spcPct val="105000"/>
-              </a:lnSpc>
-              <a:spcAft>
-                <a:spcPts val="1000"/>
-              </a:spcAft>
-            </a:pPr>
-            <a:r>
-              <a:rPr sz="1350">
-                <a:solidFill>
-                  <a:srgbClr val="18212B"/>
-                </a:solidFill>
-                <a:latin typeface="Malgun Gothic"/>
-              </a:rPr>
-              <a:t>•  Writes FASTA, indexes, profiles</a:t>
-            </a:r>
-          </a:p>
-        </p:txBody>
-      </p:sp>
-      <p:sp>
-        <p:nvSpPr>
-          <p:cNvPr id="28" name="Rounded Rectangle 27"/>
-          <p:cNvSpPr/>
-          <p:nvPr/>
-        </p:nvSpPr>
-        <p:spPr>
-          <a:xfrm>
-            <a:off x="4334255" y="3017520"/>
-            <a:ext cx="3474720" cy="2240280"/>
-          </a:xfrm>
-          <a:prstGeom prst="roundRect">
-            <a:avLst/>
-          </a:prstGeom>
-          <a:solidFill>
-            <a:srgbClr val="F5F7FA"/>
-          </a:solidFill>
-          <a:ln w="12700">
-            <a:solidFill>
-              <a:srgbClr val="D9DEE7"/>
-            </a:solidFill>
-          </a:ln>
-        </p:spPr>
-        <p:style>
-          <a:lnRef idx="1">
-            <a:schemeClr val="accent1"/>
-          </a:lnRef>
-          <a:fillRef idx="3">
-            <a:schemeClr val="accent1"/>
-          </a:fillRef>
-          <a:effectRef idx="2">
-            <a:schemeClr val="accent1"/>
-          </a:effectRef>
-          <a:fontRef idx="minor">
-            <a:schemeClr val="lt1"/>
-          </a:fontRef>
-        </p:style>
-        <p:txBody>
-          <a:bodyPr rtlCol="0" anchor="ctr"/>
-          <a:lstStyle/>
-          <a:p>
             <a:pPr algn="ctr"/>
-          </a:p>
-        </p:txBody>
-      </p:sp>
-      <p:sp>
-        <p:nvSpPr>
-          <p:cNvPr id="29" name="Rectangle 28"/>
-          <p:cNvSpPr/>
-          <p:nvPr/>
-        </p:nvSpPr>
-        <p:spPr>
-          <a:xfrm>
-            <a:off x="4334255" y="3017520"/>
-            <a:ext cx="3474720" cy="100584"/>
-          </a:xfrm>
-          <a:prstGeom prst="rect">
-            <a:avLst/>
-          </a:prstGeom>
-          <a:solidFill>
-            <a:srgbClr val="176B87"/>
-          </a:solidFill>
-          <a:ln>
-            <a:solidFill>
-              <a:srgbClr val="176B87"/>
-            </a:solidFill>
-          </a:ln>
-        </p:spPr>
-        <p:style>
-          <a:lnRef idx="1">
-            <a:schemeClr val="accent1"/>
-          </a:lnRef>
-          <a:fillRef idx="3">
-            <a:schemeClr val="accent1"/>
-          </a:fillRef>
-          <a:effectRef idx="2">
-            <a:schemeClr val="accent1"/>
-          </a:effectRef>
-          <a:fontRef idx="minor">
-            <a:schemeClr val="lt1"/>
-          </a:fontRef>
-        </p:style>
-        <p:txBody>
-          <a:bodyPr rtlCol="0" anchor="ctr"/>
-          <a:lstStyle/>
-          <a:p>
-            <a:pPr algn="ctr"/>
-          </a:p>
-        </p:txBody>
-      </p:sp>
-      <p:sp>
-        <p:nvSpPr>
-          <p:cNvPr id="30" name="TextBox 29"/>
-          <p:cNvSpPr txBox="1"/>
-          <p:nvPr/>
-        </p:nvSpPr>
-        <p:spPr>
-          <a:xfrm>
-            <a:off x="4590288" y="3310128"/>
-            <a:ext cx="3017520" cy="329184"/>
-          </a:xfrm>
-          <a:prstGeom prst="rect">
-            <a:avLst/>
-          </a:prstGeom>
-          <a:noFill/>
-        </p:spPr>
-        <p:txBody>
-          <a:bodyPr wrap="square" lIns="0" rIns="0" tIns="0" bIns="0" anchor="t">
-            <a:noAutofit/>
-          </a:bodyPr>
-          <a:lstStyle/>
-          <a:p>
-            <a:pPr algn="l"/>
-            <a:r>
-              <a:rPr sz="1800" b="1">
-                <a:solidFill>
-                  <a:srgbClr val="176B87"/>
-                </a:solidFill>
-                <a:latin typeface="Malgun Gothic"/>
-              </a:rPr>
-              <a:t>Search service</a:t>
-            </a:r>
-          </a:p>
-        </p:txBody>
-      </p:sp>
-      <p:sp>
-        <p:nvSpPr>
-          <p:cNvPr id="31" name="TextBox 30"/>
-          <p:cNvSpPr txBox="1"/>
-          <p:nvPr/>
-        </p:nvSpPr>
-        <p:spPr>
-          <a:xfrm>
-            <a:off x="4590288" y="3840480"/>
-            <a:ext cx="3017520" cy="1737360"/>
-          </a:xfrm>
-          <a:prstGeom prst="rect">
-            <a:avLst/>
-          </a:prstGeom>
-          <a:noFill/>
-        </p:spPr>
-        <p:txBody>
-          <a:bodyPr wrap="square" lIns="18288" rIns="18288" tIns="18288" bIns="18288">
-            <a:noAutofit/>
-          </a:bodyPr>
-          <a:lstStyle/>
-          <a:p>
-            <a:pPr>
-              <a:lnSpc>
-                <a:spcPct val="105000"/>
-              </a:lnSpc>
-              <a:spcAft>
-                <a:spcPts val="1000"/>
-              </a:spcAft>
-            </a:pPr>
-            <a:r>
-              <a:rPr sz="1350">
-                <a:solidFill>
-                  <a:srgbClr val="18212B"/>
-                </a:solidFill>
-                <a:latin typeface="Malgun Gothic"/>
-              </a:rPr>
-              <a:t>•  blastp, phmmer, hmmscan</a:t>
-            </a:r>
-          </a:p>
-          <a:p>
-            <a:pPr>
-              <a:lnSpc>
-                <a:spcPct val="105000"/>
-              </a:lnSpc>
-              <a:spcAft>
-                <a:spcPts val="1000"/>
-              </a:spcAft>
-            </a:pPr>
-            <a:r>
-              <a:rPr sz="1350">
-                <a:solidFill>
-                  <a:srgbClr val="18212B"/>
-                </a:solidFill>
-                <a:latin typeface="Malgun Gothic"/>
-              </a:rPr>
-              <a:t>•  Plain function, no web framework</a:t>
-            </a:r>
-          </a:p>
-          <a:p>
-            <a:pPr>
-              <a:lnSpc>
-                <a:spcPct val="105000"/>
-              </a:lnSpc>
-              <a:spcAft>
-                <a:spcPts val="1000"/>
-              </a:spcAft>
-            </a:pPr>
-            <a:r>
-              <a:rPr sz="1350">
-                <a:solidFill>
-                  <a:srgbClr val="18212B"/>
-                </a:solidFill>
-                <a:latin typeface="Malgun Gothic"/>
-              </a:rPr>
-              <a:t>•  Callable from the EnzymeX scheduler</a:t>
-            </a:r>
-          </a:p>
-        </p:txBody>
-      </p:sp>
-      <p:sp>
-        <p:nvSpPr>
-          <p:cNvPr id="32" name="Rounded Rectangle 31"/>
-          <p:cNvSpPr/>
-          <p:nvPr/>
-        </p:nvSpPr>
-        <p:spPr>
-          <a:xfrm>
-            <a:off x="8010144" y="3017520"/>
-            <a:ext cx="3474720" cy="2240280"/>
-          </a:xfrm>
-          <a:prstGeom prst="roundRect">
-            <a:avLst/>
-          </a:prstGeom>
-          <a:solidFill>
-            <a:srgbClr val="F5F7FA"/>
-          </a:solidFill>
-          <a:ln w="12700">
-            <a:solidFill>
-              <a:srgbClr val="D9DEE7"/>
-            </a:solidFill>
-          </a:ln>
-        </p:spPr>
-        <p:style>
-          <a:lnRef idx="1">
-            <a:schemeClr val="accent1"/>
-          </a:lnRef>
-          <a:fillRef idx="3">
-            <a:schemeClr val="accent1"/>
-          </a:fillRef>
-          <a:effectRef idx="2">
-            <a:schemeClr val="accent1"/>
-          </a:effectRef>
-          <a:fontRef idx="minor">
-            <a:schemeClr val="lt1"/>
-          </a:fontRef>
-        </p:style>
-        <p:txBody>
-          <a:bodyPr rtlCol="0" anchor="ctr"/>
-          <a:lstStyle/>
-          <a:p>
-            <a:pPr algn="ctr"/>
-          </a:p>
-        </p:txBody>
-      </p:sp>
-      <p:sp>
-        <p:nvSpPr>
-          <p:cNvPr id="33" name="Rectangle 32"/>
-          <p:cNvSpPr/>
-          <p:nvPr/>
-        </p:nvSpPr>
-        <p:spPr>
-          <a:xfrm>
-            <a:off x="8010144" y="3017520"/>
-            <a:ext cx="3474720" cy="100584"/>
-          </a:xfrm>
-          <a:prstGeom prst="rect">
-            <a:avLst/>
-          </a:prstGeom>
-          <a:solidFill>
-            <a:srgbClr val="167C5A"/>
-          </a:solidFill>
-          <a:ln>
-            <a:solidFill>
-              <a:srgbClr val="167C5A"/>
-            </a:solidFill>
-          </a:ln>
-        </p:spPr>
-        <p:style>
-          <a:lnRef idx="1">
-            <a:schemeClr val="accent1"/>
-          </a:lnRef>
-          <a:fillRef idx="3">
-            <a:schemeClr val="accent1"/>
-          </a:fillRef>
-          <a:effectRef idx="2">
-            <a:schemeClr val="accent1"/>
-          </a:effectRef>
-          <a:fontRef idx="minor">
-            <a:schemeClr val="lt1"/>
-          </a:fontRef>
-        </p:style>
-        <p:txBody>
-          <a:bodyPr rtlCol="0" anchor="ctr"/>
-          <a:lstStyle/>
-          <a:p>
-            <a:pPr algn="ctr"/>
-          </a:p>
-        </p:txBody>
-      </p:sp>
-      <p:sp>
-        <p:nvSpPr>
-          <p:cNvPr id="34" name="TextBox 33"/>
-          <p:cNvSpPr txBox="1"/>
-          <p:nvPr/>
-        </p:nvSpPr>
-        <p:spPr>
-          <a:xfrm>
-            <a:off x="8266175" y="3310128"/>
-            <a:ext cx="3017520" cy="329184"/>
-          </a:xfrm>
-          <a:prstGeom prst="rect">
-            <a:avLst/>
-          </a:prstGeom>
-          <a:noFill/>
-        </p:spPr>
-        <p:txBody>
-          <a:bodyPr wrap="square" lIns="0" rIns="0" tIns="0" bIns="0" anchor="t">
-            <a:noAutofit/>
-          </a:bodyPr>
-          <a:lstStyle/>
-          <a:p>
-            <a:pPr algn="l"/>
-            <a:r>
-              <a:rPr sz="1800" b="1">
-                <a:solidFill>
-                  <a:srgbClr val="167C5A"/>
-                </a:solidFill>
-                <a:latin typeface="Malgun Gothic"/>
-              </a:rPr>
-              <a:t>Result page</a:t>
-            </a:r>
-          </a:p>
-        </p:txBody>
-      </p:sp>
-      <p:sp>
-        <p:nvSpPr>
-          <p:cNvPr id="35" name="TextBox 34"/>
-          <p:cNvSpPr txBox="1"/>
-          <p:nvPr/>
-        </p:nvSpPr>
-        <p:spPr>
-          <a:xfrm>
-            <a:off x="8266175" y="3840480"/>
-            <a:ext cx="3017520" cy="1737360"/>
-          </a:xfrm>
-          <a:prstGeom prst="rect">
-            <a:avLst/>
-          </a:prstGeom>
-          <a:noFill/>
-        </p:spPr>
-        <p:txBody>
-          <a:bodyPr wrap="square" lIns="18288" rIns="18288" tIns="18288" bIns="18288">
-            <a:noAutofit/>
-          </a:bodyPr>
-          <a:lstStyle/>
-          <a:p>
-            <a:pPr>
-              <a:lnSpc>
-                <a:spcPct val="105000"/>
-              </a:lnSpc>
-              <a:spcAft>
-                <a:spcPts val="1000"/>
-              </a:spcAft>
-            </a:pPr>
-            <a:r>
-              <a:rPr sz="1350">
-                <a:solidFill>
-                  <a:srgbClr val="18212B"/>
-                </a:solidFill>
-                <a:latin typeface="Malgun Gothic"/>
-              </a:rPr>
-              <a:t>•  One table per method</a:t>
-            </a:r>
-          </a:p>
-          <a:p>
-            <a:pPr>
-              <a:lnSpc>
-                <a:spcPct val="105000"/>
-              </a:lnSpc>
-              <a:spcAft>
-                <a:spcPts val="1000"/>
-              </a:spcAft>
-            </a:pPr>
-            <a:r>
-              <a:rPr sz="1350">
-                <a:solidFill>
-                  <a:srgbClr val="18212B"/>
-                </a:solidFill>
-                <a:latin typeface="Malgun Gothic"/>
-              </a:rPr>
-              <a:t>•  EC, source, description per hit</a:t>
-            </a:r>
-          </a:p>
-          <a:p>
-            <a:pPr>
-              <a:lnSpc>
-                <a:spcPct val="105000"/>
-              </a:lnSpc>
-              <a:spcAft>
-                <a:spcPts val="1000"/>
-              </a:spcAft>
-            </a:pPr>
-            <a:r>
-              <a:rPr sz="1350">
-                <a:solidFill>
-                  <a:srgbClr val="18212B"/>
-                </a:solidFill>
-                <a:latin typeface="Malgun Gothic"/>
-              </a:rPr>
-              <a:t>•  CSV and JSON export</a:t>
+            <a:r>
+              <a:rPr sz="1350" b="1">
+                <a:solidFill>
+                  <a:srgbClr val="52565B"/>
+                </a:solidFill>
+                <a:latin typeface="Malgun Gothic"/>
+              </a:rPr>
+              <a:t>Step 1 is the only database connection in the entire flow. Everything after it reads files written by step 2.</a:t>
             </a:r>
           </a:p>
         </p:txBody>

</xml_diff>

<commit_message>
cut filler lines from the deck
</commit_message>
<xml_diff>
--- a/docs/presentations/EnzymeX_BLAST_HMMER_update.pptx
+++ b/docs/presentations/EnzymeX_BLAST_HMMER_update.pptx
@@ -4182,48 +4182,13 @@
       </p:sp>
       <p:sp>
         <p:nvSpPr>
-          <p:cNvPr id="5" name="TextBox 4"/>
-          <p:cNvSpPr txBox="1"/>
-          <p:nvPr/>
-        </p:nvSpPr>
-        <p:spPr>
-          <a:xfrm>
-            <a:off x="941832" y="3493008"/>
-            <a:ext cx="10058400" cy="457200"/>
-          </a:xfrm>
-          <a:prstGeom prst="rect">
-            <a:avLst/>
-          </a:prstGeom>
-          <a:noFill/>
-        </p:spPr>
-        <p:txBody>
-          <a:bodyPr wrap="square" lIns="0" rIns="0" tIns="0" bIns="0" anchor="t">
-            <a:noAutofit/>
-          </a:bodyPr>
-          <a:lstStyle/>
-          <a:p>
-            <a:pPr algn="l"/>
-            <a:r>
-              <a:rPr sz="2000" b="0">
-                <a:solidFill>
-                  <a:srgbClr val="52565B"/>
-                </a:solidFill>
-                <a:latin typeface="Malgun Gothic"/>
-              </a:rPr>
-              <a:t>Sequence similarity search for the result page</a:t>
-            </a:r>
-          </a:p>
-        </p:txBody>
-      </p:sp>
-      <p:sp>
-        <p:nvSpPr>
-          <p:cNvPr id="6" name="Rounded Rectangle 5"/>
+          <p:cNvPr id="5" name="Rounded Rectangle 4"/>
           <p:cNvSpPr/>
           <p:nvPr/>
         </p:nvSpPr>
         <p:spPr>
           <a:xfrm>
-            <a:off x="941832" y="4206240"/>
+            <a:off x="941832" y="3611880"/>
             <a:ext cx="1024128" cy="310896"/>
           </a:xfrm>
           <a:prstGeom prst="roundRect">
@@ -4262,13 +4227,13 @@
       </p:sp>
       <p:sp>
         <p:nvSpPr>
-          <p:cNvPr id="7" name="TextBox 6"/>
+          <p:cNvPr id="6" name="TextBox 5"/>
           <p:cNvSpPr txBox="1"/>
           <p:nvPr/>
         </p:nvSpPr>
         <p:spPr>
           <a:xfrm>
-            <a:off x="978408" y="4215383"/>
+            <a:off x="978408" y="3621024"/>
             <a:ext cx="950976" cy="256032"/>
           </a:xfrm>
           <a:prstGeom prst="rect">
@@ -4297,13 +4262,13 @@
       </p:sp>
       <p:sp>
         <p:nvSpPr>
-          <p:cNvPr id="8" name="Rounded Rectangle 7"/>
+          <p:cNvPr id="7" name="Rounded Rectangle 6"/>
           <p:cNvSpPr/>
           <p:nvPr/>
         </p:nvSpPr>
         <p:spPr>
           <a:xfrm>
-            <a:off x="2103120" y="4206240"/>
+            <a:off x="2103120" y="3611880"/>
             <a:ext cx="1115568" cy="310896"/>
           </a:xfrm>
           <a:prstGeom prst="roundRect">
@@ -4342,13 +4307,13 @@
       </p:sp>
       <p:sp>
         <p:nvSpPr>
-          <p:cNvPr id="9" name="TextBox 8"/>
+          <p:cNvPr id="8" name="TextBox 7"/>
           <p:cNvSpPr txBox="1"/>
           <p:nvPr/>
         </p:nvSpPr>
         <p:spPr>
           <a:xfrm>
-            <a:off x="2139696" y="4215383"/>
+            <a:off x="2139696" y="3621024"/>
             <a:ext cx="1042415" cy="256032"/>
           </a:xfrm>
           <a:prstGeom prst="rect">
@@ -4377,13 +4342,13 @@
       </p:sp>
       <p:sp>
         <p:nvSpPr>
-          <p:cNvPr id="10" name="Rounded Rectangle 9"/>
+          <p:cNvPr id="9" name="Rounded Rectangle 8"/>
           <p:cNvSpPr/>
           <p:nvPr/>
         </p:nvSpPr>
         <p:spPr>
           <a:xfrm>
-            <a:off x="3355848" y="4206240"/>
+            <a:off x="3355848" y="3611880"/>
             <a:ext cx="1188720" cy="310896"/>
           </a:xfrm>
           <a:prstGeom prst="roundRect">
@@ -4422,47 +4387,47 @@
       </p:sp>
       <p:sp>
         <p:nvSpPr>
+          <p:cNvPr id="10" name="TextBox 9"/>
+          <p:cNvSpPr txBox="1"/>
+          <p:nvPr/>
+        </p:nvSpPr>
+        <p:spPr>
+          <a:xfrm>
+            <a:off x="3392424" y="3621024"/>
+            <a:ext cx="1115568" cy="256032"/>
+          </a:xfrm>
+          <a:prstGeom prst="rect">
+            <a:avLst/>
+          </a:prstGeom>
+          <a:noFill/>
+        </p:spPr>
+        <p:txBody>
+          <a:bodyPr wrap="square" lIns="0" rIns="0" tIns="0" bIns="0" anchor="ctr">
+            <a:noAutofit/>
+          </a:bodyPr>
+          <a:lstStyle/>
+          <a:p>
+            <a:pPr algn="ctr"/>
+            <a:r>
+              <a:rPr sz="1050" b="1">
+                <a:solidFill>
+                  <a:srgbClr val="6554A4"/>
+                </a:solidFill>
+                <a:latin typeface="Malgun Gothic"/>
+              </a:rPr>
+              <a:t>hmmscan</a:t>
+            </a:r>
+          </a:p>
+        </p:txBody>
+      </p:sp>
+      <p:sp>
+        <p:nvSpPr>
           <p:cNvPr id="11" name="TextBox 10"/>
           <p:cNvSpPr txBox="1"/>
           <p:nvPr/>
         </p:nvSpPr>
         <p:spPr>
           <a:xfrm>
-            <a:off x="3392424" y="4215383"/>
-            <a:ext cx="1115568" cy="256032"/>
-          </a:xfrm>
-          <a:prstGeom prst="rect">
-            <a:avLst/>
-          </a:prstGeom>
-          <a:noFill/>
-        </p:spPr>
-        <p:txBody>
-          <a:bodyPr wrap="square" lIns="0" rIns="0" tIns="0" bIns="0" anchor="ctr">
-            <a:noAutofit/>
-          </a:bodyPr>
-          <a:lstStyle/>
-          <a:p>
-            <a:pPr algn="ctr"/>
-            <a:r>
-              <a:rPr sz="1050" b="1">
-                <a:solidFill>
-                  <a:srgbClr val="6554A4"/>
-                </a:solidFill>
-                <a:latin typeface="Malgun Gothic"/>
-              </a:rPr>
-              <a:t>hmmscan</a:t>
-            </a:r>
-          </a:p>
-        </p:txBody>
-      </p:sp>
-      <p:sp>
-        <p:nvSpPr>
-          <p:cNvPr id="12" name="TextBox 11"/>
-          <p:cNvSpPr txBox="1"/>
-          <p:nvPr/>
-        </p:nvSpPr>
-        <p:spPr>
-          <a:xfrm>
             <a:off x="941832" y="5806440"/>
             <a:ext cx="5486400" cy="320040"/>
           </a:xfrm>
@@ -4492,7 +4457,7 @@
       </p:sp>
       <p:sp>
         <p:nvSpPr>
-          <p:cNvPr id="13" name="TextBox 12"/>
+          <p:cNvPr id="12" name="TextBox 11"/>
           <p:cNvSpPr txBox="1"/>
           <p:nvPr/>
         </p:nvSpPr>
@@ -6393,7 +6358,7 @@
                 </a:solidFill>
                 <a:latin typeface="Malgun Gothic"/>
               </a:rPr>
-              <a:t>Step 1 is the only database connection in the entire flow. Everything after it reads files written by step 2.</a:t>
+              <a:t>Step 1 is the only database connection in the entire flow.</a:t>
             </a:r>
           </a:p>
         </p:txBody>
@@ -8261,86 +8226,6 @@
           </a:p>
         </p:txBody>
       </p:sp>
-      <p:sp>
-        <p:nvSpPr>
-          <p:cNvPr id="51" name="Rounded Rectangle 50"/>
-          <p:cNvSpPr/>
-          <p:nvPr/>
-        </p:nvSpPr>
-        <p:spPr>
-          <a:xfrm>
-            <a:off x="658368" y="5806440"/>
-            <a:ext cx="10881360" cy="566928"/>
-          </a:xfrm>
-          <a:prstGeom prst="roundRect">
-            <a:avLst/>
-          </a:prstGeom>
-          <a:solidFill>
-            <a:srgbClr val="F5F7FA"/>
-          </a:solidFill>
-          <a:ln w="12700">
-            <a:solidFill>
-              <a:srgbClr val="D9DEE7"/>
-            </a:solidFill>
-          </a:ln>
-        </p:spPr>
-        <p:style>
-          <a:lnRef idx="1">
-            <a:schemeClr val="accent1"/>
-          </a:lnRef>
-          <a:fillRef idx="3">
-            <a:schemeClr val="accent1"/>
-          </a:fillRef>
-          <a:effectRef idx="2">
-            <a:schemeClr val="accent1"/>
-          </a:effectRef>
-          <a:fontRef idx="minor">
-            <a:schemeClr val="lt1"/>
-          </a:fontRef>
-        </p:style>
-        <p:txBody>
-          <a:bodyPr rtlCol="0" anchor="ctr"/>
-          <a:lstStyle/>
-          <a:p>
-            <a:pPr algn="ctr"/>
-          </a:p>
-        </p:txBody>
-      </p:sp>
-      <p:sp>
-        <p:nvSpPr>
-          <p:cNvPr id="52" name="TextBox 51"/>
-          <p:cNvSpPr txBox="1"/>
-          <p:nvPr/>
-        </p:nvSpPr>
-        <p:spPr>
-          <a:xfrm>
-            <a:off x="658368" y="5971032"/>
-            <a:ext cx="10881360" cy="274320"/>
-          </a:xfrm>
-          <a:prstGeom prst="rect">
-            <a:avLst/>
-          </a:prstGeom>
-          <a:noFill/>
-        </p:spPr>
-        <p:txBody>
-          <a:bodyPr wrap="square" lIns="0" rIns="0" tIns="0" bIns="0" anchor="t">
-            <a:noAutofit/>
-          </a:bodyPr>
-          <a:lstStyle/>
-          <a:p>
-            <a:pPr algn="ctr"/>
-            <a:r>
-              <a:rPr sz="1350" b="1">
-                <a:solidFill>
-                  <a:srgbClr val="52565B"/>
-                </a:solidFill>
-                <a:latin typeface="Malgun Gothic"/>
-              </a:rPr>
-              <a:t>Same language, same database engine. The integration point is one function call from the existing scheduler.</a:t>
-            </a:r>
-          </a:p>
-        </p:txBody>
-      </p:sp>
     </p:spTree>
   </p:cSld>
   <p:clrMapOvr>
@@ -11603,7 +11488,7 @@
         </p:nvSpPr>
         <p:spPr>
           <a:xfrm>
-            <a:off x="5120640" y="1965960"/>
+            <a:off x="5120640" y="2148840"/>
             <a:ext cx="6217920" cy="1188720"/>
           </a:xfrm>
           <a:prstGeom prst="rect">
@@ -11652,25 +11537,6 @@
                 <a:latin typeface="Malgun Gothic"/>
               </a:rPr>
               <a:t>•  BLAST+ 2.5, evalue 1e-5, max_target_seqs 100</a:t>
-            </a:r>
-          </a:p>
-          <a:p>
-            <a:pPr>
-              <a:lnSpc>
-                <a:spcPct val="105000"/>
-              </a:lnSpc>
-              <a:spcAft>
-                <a:spcPts val="1000"/>
-              </a:spcAft>
-            </a:pPr>
-            <a:r>
-              <a:rPr sz="1500">
-                <a:solidFill>
-                  <a:srgbClr val="18212B"/>
-                </a:solidFill>
-                <a:latin typeface="Malgun Gothic"/>
-              </a:rPr>
-              <a:t>•  Confirms the pipeline reproduces the existing result</a:t>
             </a:r>
           </a:p>
         </p:txBody>

</xml_diff>